<commit_message>
Galp Q3 2026: refocus the update on the terminated Moeve downstream merger
Chart 1 now compares the results-day share price fall with the synergy value
analysts assigned to the deal; page-1 text, KPI strip and page-2 deal section
rewritten around the merger collapse, with Brazil as a secondary risk.

Co-Authored-By: Claude Opus 5.5 <noreply@anthropic.com>
Claude-Session: https://claude.ai/code/session_01GhQ2PLYzYFZ38n9VawGH3T
</commit_message>
<xml_diff>
--- a/outputs/GALP_Q3_2026/Earnings_Update_GALP_Q32026.pptx
+++ b/outputs/GALP_Q3_2026/Earnings_Update_GALP_Q32026.pptx
@@ -1227,7 +1227,7 @@
         <p:spPr>
           <a:xfrm>
             <a:off x="539496" y="1028700"/>
-            <a:ext cx="6483096" cy="526796"/>
+            <a:ext cx="6483096" cy="263398"/>
           </a:xfrm>
           <a:prstGeom prst="rect">
             <a:avLst/>
@@ -1254,7 +1254,7 @@
                 <a:ea typeface="Nunito" pitchFamily="34" charset="-122"/>
                 <a:cs typeface="Nunito" pitchFamily="34" charset="-120"/>
               </a:rPr>
-              <a:t>Galp Q3 2026: guidance raised, deal dropped, the sell-off goes too far</a:t>
+              <a:t>Galp Q3 2026: Moeve collapse hits the stock, not the case</a:t>
             </a:r>
             <a:endParaRPr lang="en-US" sz="1700" dirty="0"/>
           </a:p>
@@ -1268,7 +1268,7 @@
         </p:nvSpPr>
         <p:spPr>
           <a:xfrm>
-            <a:off x="539496" y="1592072"/>
+            <a:off x="539496" y="1328674"/>
             <a:ext cx="6483096" cy="164592"/>
           </a:xfrm>
           <a:prstGeom prst="rect">
@@ -1307,7 +1307,7 @@
         </p:nvSpPr>
         <p:spPr>
           <a:xfrm>
-            <a:off x="539496" y="1875536"/>
+            <a:off x="539496" y="1612138"/>
             <a:ext cx="42977" cy="573786"/>
           </a:xfrm>
           <a:prstGeom prst="rect">
@@ -1332,7 +1332,7 @@
         </p:nvSpPr>
         <p:spPr>
           <a:xfrm>
-            <a:off x="722376" y="1893824"/>
+            <a:off x="722376" y="1630426"/>
             <a:ext cx="6300216" cy="336042"/>
           </a:xfrm>
           <a:prstGeom prst="rect">
@@ -1374,7 +1374,7 @@
         </p:nvSpPr>
         <p:spPr>
           <a:xfrm>
-            <a:off x="722376" y="2266442"/>
+            <a:off x="722376" y="2003044"/>
             <a:ext cx="6300216" cy="155448"/>
           </a:xfrm>
           <a:prstGeom prst="rect">
@@ -1413,7 +1413,7 @@
         </p:nvSpPr>
         <p:spPr>
           <a:xfrm>
-            <a:off x="539496" y="2568194"/>
+            <a:off x="539496" y="2304796"/>
             <a:ext cx="6483096" cy="219456"/>
           </a:xfrm>
           <a:prstGeom prst="rect">
@@ -1452,7 +1452,7 @@
         </p:nvSpPr>
         <p:spPr>
           <a:xfrm>
-            <a:off x="539496" y="2828798"/>
+            <a:off x="539496" y="2565400"/>
             <a:ext cx="576072" cy="156896"/>
           </a:xfrm>
           <a:prstGeom prst="rect">
@@ -1471,13 +1471,13 @@
             <a:r>
               <a:rPr lang="en-US" sz="700" b="1" spc="80" kern="0" dirty="0">
                 <a:solidFill>
-                  <a:srgbClr val="3BAF90"/>
-                </a:solidFill>
-                <a:latin typeface="Nunito" pitchFamily="34" charset="0"/>
-                <a:ea typeface="Nunito" pitchFamily="34" charset="-122"/>
-                <a:cs typeface="Nunito" pitchFamily="34" charset="-120"/>
-              </a:rPr>
-              <a:t>Beat</a:t>
+                  <a:srgbClr val="FF6C0E"/>
+                </a:solidFill>
+                <a:latin typeface="Nunito" pitchFamily="34" charset="0"/>
+                <a:ea typeface="Nunito" pitchFamily="34" charset="-122"/>
+                <a:cs typeface="Nunito" pitchFamily="34" charset="-120"/>
+              </a:rPr>
+              <a:t>Deal</a:t>
             </a:r>
             <a:endParaRPr lang="en-US" sz="700" dirty="0"/>
           </a:p>
@@ -1491,7 +1491,7 @@
         </p:nvSpPr>
         <p:spPr>
           <a:xfrm>
-            <a:off x="1133856" y="2805938"/>
+            <a:off x="1133856" y="2542540"/>
             <a:ext cx="5888736" cy="156896"/>
           </a:xfrm>
           <a:prstGeom prst="rect">
@@ -1519,7 +1519,7 @@
                 <a:ea typeface="Nunito" pitchFamily="34" charset="-122"/>
                 <a:cs typeface="Nunito" pitchFamily="34" charset="-120"/>
               </a:rPr>
-              <a:t>RCA EBITDA of EUR 1,522m rose 67% and came in 3.5% above consensus, led by Bacalhau and refining.</a:t>
+              <a:t>The Moeve downstream merger ended after ten months of talks, removing c.EUR 1.1 per share of synergies.</a:t>
             </a:r>
             <a:endParaRPr lang="en-US" sz="870" dirty="0"/>
           </a:p>
@@ -1533,7 +1533,7 @@
         </p:nvSpPr>
         <p:spPr>
           <a:xfrm>
-            <a:off x="539496" y="3031414"/>
+            <a:off x="539496" y="2768016"/>
             <a:ext cx="576072" cy="156896"/>
           </a:xfrm>
           <a:prstGeom prst="rect">
@@ -1558,7 +1558,7 @@
                 <a:ea typeface="Nunito" pitchFamily="34" charset="-122"/>
                 <a:cs typeface="Nunito" pitchFamily="34" charset="-120"/>
               </a:rPr>
-              <a:t>Raised</a:t>
+              <a:t>Beat</a:t>
             </a:r>
             <a:endParaRPr lang="en-US" sz="700" dirty="0"/>
           </a:p>
@@ -1572,7 +1572,7 @@
         </p:nvSpPr>
         <p:spPr>
           <a:xfrm>
-            <a:off x="1133856" y="3008554"/>
+            <a:off x="1133856" y="2745156"/>
             <a:ext cx="5888736" cy="156896"/>
           </a:xfrm>
           <a:prstGeom prst="rect">
@@ -1600,7 +1600,7 @@
                 <a:ea typeface="Nunito" pitchFamily="34" charset="-122"/>
                 <a:cs typeface="Nunito" pitchFamily="34" charset="-120"/>
               </a:rPr>
-              <a:t>Full-year EBITDA guidance lifted to c.EUR 5bn from c.EUR 4bn, operating cash flow to c.EUR 3.9bn.</a:t>
+              <a:t>Q3 RCA EBITDA of EUR 1,522m rose 67%, 3.5% above consensus, on Bacalhau and refining.</a:t>
             </a:r>
             <a:endParaRPr lang="en-US" sz="870" dirty="0"/>
           </a:p>
@@ -1614,7 +1614,7 @@
         </p:nvSpPr>
         <p:spPr>
           <a:xfrm>
-            <a:off x="539496" y="3234030"/>
+            <a:off x="539496" y="2970632"/>
             <a:ext cx="576072" cy="156896"/>
           </a:xfrm>
           <a:prstGeom prst="rect">
@@ -1633,13 +1633,13 @@
             <a:r>
               <a:rPr lang="en-US" sz="700" b="1" spc="80" kern="0" dirty="0">
                 <a:solidFill>
-                  <a:srgbClr val="FF6C0E"/>
-                </a:solidFill>
-                <a:latin typeface="Nunito" pitchFamily="34" charset="0"/>
-                <a:ea typeface="Nunito" pitchFamily="34" charset="-122"/>
-                <a:cs typeface="Nunito" pitchFamily="34" charset="-120"/>
-              </a:rPr>
-              <a:t>Watch</a:t>
+                  <a:srgbClr val="3BAF90"/>
+                </a:solidFill>
+                <a:latin typeface="Nunito" pitchFamily="34" charset="0"/>
+                <a:ea typeface="Nunito" pitchFamily="34" charset="-122"/>
+                <a:cs typeface="Nunito" pitchFamily="34" charset="-120"/>
+              </a:rPr>
+              <a:t>Raised</a:t>
             </a:r>
             <a:endParaRPr lang="en-US" sz="700" dirty="0"/>
           </a:p>
@@ -1653,7 +1653,7 @@
         </p:nvSpPr>
         <p:spPr>
           <a:xfrm>
-            <a:off x="1133856" y="3211170"/>
+            <a:off x="1133856" y="2947772"/>
             <a:ext cx="5888736" cy="156896"/>
           </a:xfrm>
           <a:prstGeom prst="rect">
@@ -1681,7 +1681,7 @@
                 <a:ea typeface="Nunito" pitchFamily="34" charset="-122"/>
                 <a:cs typeface="Nunito" pitchFamily="34" charset="-120"/>
               </a:rPr>
-              <a:t>Moeve downstream talks ended without a deal, removing c.EUR 1.1 per share of expected synergy value.</a:t>
+              <a:t>Full-year EBITDA guidance lifted to c.EUR 5bn from c.EUR 4bn, operating cash flow to c.EUR 3.9bn.</a:t>
             </a:r>
             <a:endParaRPr lang="en-US" sz="870" dirty="0"/>
           </a:p>
@@ -1695,7 +1695,7 @@
         </p:nvSpPr>
         <p:spPr>
           <a:xfrm>
-            <a:off x="539496" y="3436645"/>
+            <a:off x="539496" y="3173247"/>
             <a:ext cx="576072" cy="156896"/>
           </a:xfrm>
           <a:prstGeom prst="rect">
@@ -1734,7 +1734,7 @@
         </p:nvSpPr>
         <p:spPr>
           <a:xfrm>
-            <a:off x="1133856" y="3413785"/>
+            <a:off x="1133856" y="3150387"/>
             <a:ext cx="5888736" cy="156896"/>
           </a:xfrm>
           <a:prstGeom prst="rect">
@@ -1762,7 +1762,7 @@
                 <a:ea typeface="Nunito" pitchFamily="34" charset="-122"/>
                 <a:cs typeface="Nunito" pitchFamily="34" charset="-120"/>
               </a:rPr>
-              <a:t>The 8.8% results-day fall leaves 8.4x forward earnings, 27% below the 2022 to 2026 average.</a:t>
+              <a:t>The 8.8% fall, nearly twice the synergy value, leaves 8.4x forward earnings, 27% below average.</a:t>
             </a:r>
             <a:endParaRPr lang="en-US" sz="870" dirty="0"/>
           </a:p>
@@ -1776,7 +1776,7 @@
         </p:nvSpPr>
         <p:spPr>
           <a:xfrm>
-            <a:off x="539496" y="3698697"/>
+            <a:off x="539496" y="3435299"/>
             <a:ext cx="6483096" cy="676656"/>
           </a:xfrm>
           <a:prstGeom prst="rect">
@@ -1801,7 +1801,7 @@
         </p:nvSpPr>
         <p:spPr>
           <a:xfrm>
-            <a:off x="649224" y="3780993"/>
+            <a:off x="649224" y="3517595"/>
             <a:ext cx="1437894" cy="146304"/>
           </a:xfrm>
           <a:prstGeom prst="rect">
@@ -1826,7 +1826,7 @@
                 <a:ea typeface="Nunito" pitchFamily="34" charset="-122"/>
                 <a:cs typeface="Nunito" pitchFamily="34" charset="-120"/>
               </a:rPr>
-              <a:t>RCA EBITDA</a:t>
+              <a:t>Lost synergies per share</a:t>
             </a:r>
             <a:endParaRPr lang="en-US" sz="720" dirty="0"/>
           </a:p>
@@ -1840,7 +1840,7 @@
         </p:nvSpPr>
         <p:spPr>
           <a:xfrm>
-            <a:off x="649224" y="3927297"/>
+            <a:off x="649224" y="3663899"/>
             <a:ext cx="1437894" cy="237744"/>
           </a:xfrm>
           <a:prstGeom prst="rect">
@@ -1865,7 +1865,7 @@
                 <a:ea typeface="Nunito" pitchFamily="34" charset="-122"/>
                 <a:cs typeface="Nunito" pitchFamily="34" charset="-120"/>
               </a:rPr>
-              <a:t>EUR 1,522m</a:t>
+              <a:t>c.EUR 1.1</a:t>
             </a:r>
             <a:endParaRPr lang="en-US" sz="1300" dirty="0"/>
           </a:p>
@@ -1879,7 +1879,7 @@
         </p:nvSpPr>
         <p:spPr>
           <a:xfrm>
-            <a:off x="649224" y="4165041"/>
+            <a:off x="649224" y="3901643"/>
             <a:ext cx="1437894" cy="146304"/>
           </a:xfrm>
           <a:prstGeom prst="rect">
@@ -1898,13 +1898,13 @@
             <a:r>
               <a:rPr lang="en-US" sz="720" b="1" dirty="0">
                 <a:solidFill>
-                  <a:srgbClr val="3BAF90"/>
-                </a:solidFill>
-                <a:latin typeface="Nunito" pitchFamily="34" charset="0"/>
-                <a:ea typeface="Nunito" pitchFamily="34" charset="-122"/>
-                <a:cs typeface="Nunito" pitchFamily="34" charset="-120"/>
-              </a:rPr>
-              <a:t>+3.5% vs. consensus</a:t>
+                  <a:srgbClr val="FF6C0E"/>
+                </a:solidFill>
+                <a:latin typeface="Nunito" pitchFamily="34" charset="0"/>
+                <a:ea typeface="Nunito" pitchFamily="34" charset="-122"/>
+                <a:cs typeface="Nunito" pitchFamily="34" charset="-120"/>
+              </a:rPr>
+              <a:t>EUR 750 to 800m in total</a:t>
             </a:r>
             <a:endParaRPr lang="en-US" sz="720" dirty="0"/>
           </a:p>
@@ -1918,7 +1918,7 @@
         </p:nvSpPr>
         <p:spPr>
           <a:xfrm>
-            <a:off x="2160270" y="3698697"/>
+            <a:off x="2160270" y="3435299"/>
             <a:ext cx="0" cy="676656"/>
           </a:xfrm>
           <a:prstGeom prst="line">
@@ -1941,7 +1941,7 @@
         </p:nvSpPr>
         <p:spPr>
           <a:xfrm>
-            <a:off x="2269998" y="3780993"/>
+            <a:off x="2269998" y="3517595"/>
             <a:ext cx="1437894" cy="146304"/>
           </a:xfrm>
           <a:prstGeom prst="rect">
@@ -1966,7 +1966,7 @@
                 <a:ea typeface="Nunito" pitchFamily="34" charset="-122"/>
                 <a:cs typeface="Nunito" pitchFamily="34" charset="-120"/>
               </a:rPr>
-              <a:t>RCA net income</a:t>
+              <a:t>Results-day share move</a:t>
             </a:r>
             <a:endParaRPr lang="en-US" sz="720" dirty="0"/>
           </a:p>
@@ -1980,7 +1980,7 @@
         </p:nvSpPr>
         <p:spPr>
           <a:xfrm>
-            <a:off x="2269998" y="3927297"/>
+            <a:off x="2269998" y="3663899"/>
             <a:ext cx="1437894" cy="237744"/>
           </a:xfrm>
           <a:prstGeom prst="rect">
@@ -2005,7 +2005,7 @@
                 <a:ea typeface="Nunito" pitchFamily="34" charset="-122"/>
                 <a:cs typeface="Nunito" pitchFamily="34" charset="-120"/>
               </a:rPr>
-              <a:t>EUR 682m</a:t>
+              <a:t>-8.8%</a:t>
             </a:r>
             <a:endParaRPr lang="en-US" sz="1300" dirty="0"/>
           </a:p>
@@ -2019,7 +2019,7 @@
         </p:nvSpPr>
         <p:spPr>
           <a:xfrm>
-            <a:off x="2269998" y="4165041"/>
+            <a:off x="2269998" y="3901643"/>
             <a:ext cx="1437894" cy="146304"/>
           </a:xfrm>
           <a:prstGeom prst="rect">
@@ -2038,13 +2038,13 @@
             <a:r>
               <a:rPr lang="en-US" sz="720" b="1" dirty="0">
                 <a:solidFill>
-                  <a:srgbClr val="3BAF90"/>
-                </a:solidFill>
-                <a:latin typeface="Nunito" pitchFamily="34" charset="0"/>
-                <a:ea typeface="Nunito" pitchFamily="34" charset="-122"/>
-                <a:cs typeface="Nunito" pitchFamily="34" charset="-120"/>
-              </a:rPr>
-              <a:t>+68% year on year</a:t>
+                  <a:srgbClr val="FF6C0E"/>
+                </a:solidFill>
+                <a:latin typeface="Nunito" pitchFamily="34" charset="0"/>
+                <a:ea typeface="Nunito" pitchFamily="34" charset="-122"/>
+                <a:cs typeface="Nunito" pitchFamily="34" charset="-120"/>
+              </a:rPr>
+              <a:t>-EUR 2.03 per share</a:t>
             </a:r>
             <a:endParaRPr lang="en-US" sz="720" dirty="0"/>
           </a:p>
@@ -2058,7 +2058,7 @@
         </p:nvSpPr>
         <p:spPr>
           <a:xfrm>
-            <a:off x="3781044" y="3698697"/>
+            <a:off x="3781044" y="3435299"/>
             <a:ext cx="0" cy="676656"/>
           </a:xfrm>
           <a:prstGeom prst="line">
@@ -2081,7 +2081,7 @@
         </p:nvSpPr>
         <p:spPr>
           <a:xfrm>
-            <a:off x="3890772" y="3780993"/>
+            <a:off x="3890772" y="3517595"/>
             <a:ext cx="1437894" cy="146304"/>
           </a:xfrm>
           <a:prstGeom prst="rect">
@@ -2106,7 +2106,7 @@
                 <a:ea typeface="Nunito" pitchFamily="34" charset="-122"/>
                 <a:cs typeface="Nunito" pitchFamily="34" charset="-120"/>
               </a:rPr>
-              <a:t>FY26 EBITDA guide</a:t>
+              <a:t>RCA EBITDA</a:t>
             </a:r>
             <a:endParaRPr lang="en-US" sz="720" dirty="0"/>
           </a:p>
@@ -2120,7 +2120,7 @@
         </p:nvSpPr>
         <p:spPr>
           <a:xfrm>
-            <a:off x="3890772" y="3927297"/>
+            <a:off x="3890772" y="3663899"/>
             <a:ext cx="1437894" cy="237744"/>
           </a:xfrm>
           <a:prstGeom prst="rect">
@@ -2145,7 +2145,7 @@
                 <a:ea typeface="Nunito" pitchFamily="34" charset="-122"/>
                 <a:cs typeface="Nunito" pitchFamily="34" charset="-120"/>
               </a:rPr>
-              <a:t>c.EUR 5.0bn</a:t>
+              <a:t>EUR 1,522m</a:t>
             </a:r>
             <a:endParaRPr lang="en-US" sz="1300" dirty="0"/>
           </a:p>
@@ -2159,7 +2159,7 @@
         </p:nvSpPr>
         <p:spPr>
           <a:xfrm>
-            <a:off x="3890772" y="4165041"/>
+            <a:off x="3890772" y="3901643"/>
             <a:ext cx="1437894" cy="146304"/>
           </a:xfrm>
           <a:prstGeom prst="rect">
@@ -2184,7 +2184,7 @@
                 <a:ea typeface="Nunito" pitchFamily="34" charset="-122"/>
                 <a:cs typeface="Nunito" pitchFamily="34" charset="-120"/>
               </a:rPr>
-              <a:t>+25% vs. prior guide</a:t>
+              <a:t>+3.5% vs. consensus</a:t>
             </a:r>
             <a:endParaRPr lang="en-US" sz="720" dirty="0"/>
           </a:p>
@@ -2198,7 +2198,7 @@
         </p:nvSpPr>
         <p:spPr>
           <a:xfrm>
-            <a:off x="5401818" y="3698697"/>
+            <a:off x="5401818" y="3435299"/>
             <a:ext cx="0" cy="676656"/>
           </a:xfrm>
           <a:prstGeom prst="line">
@@ -2221,7 +2221,7 @@
         </p:nvSpPr>
         <p:spPr>
           <a:xfrm>
-            <a:off x="5511546" y="3780993"/>
+            <a:off x="5511546" y="3517595"/>
             <a:ext cx="1437894" cy="146304"/>
           </a:xfrm>
           <a:prstGeom prst="rect">
@@ -2246,7 +2246,7 @@
                 <a:ea typeface="Nunito" pitchFamily="34" charset="-122"/>
                 <a:cs typeface="Nunito" pitchFamily="34" charset="-120"/>
               </a:rPr>
-              <a:t>Net debt</a:t>
+              <a:t>FY26 EBITDA guide</a:t>
             </a:r>
             <a:endParaRPr lang="en-US" sz="720" dirty="0"/>
           </a:p>
@@ -2260,7 +2260,7 @@
         </p:nvSpPr>
         <p:spPr>
           <a:xfrm>
-            <a:off x="5511546" y="3927297"/>
+            <a:off x="5511546" y="3663899"/>
             <a:ext cx="1437894" cy="237744"/>
           </a:xfrm>
           <a:prstGeom prst="rect">
@@ -2285,7 +2285,7 @@
                 <a:ea typeface="Nunito" pitchFamily="34" charset="-122"/>
                 <a:cs typeface="Nunito" pitchFamily="34" charset="-120"/>
               </a:rPr>
-              <a:t>EUR 1.43bn</a:t>
+              <a:t>c.EUR 5.0bn</a:t>
             </a:r>
             <a:endParaRPr lang="en-US" sz="1300" dirty="0"/>
           </a:p>
@@ -2299,7 +2299,7 @@
         </p:nvSpPr>
         <p:spPr>
           <a:xfrm>
-            <a:off x="5511546" y="4165041"/>
+            <a:off x="5511546" y="3901643"/>
             <a:ext cx="1437894" cy="146304"/>
           </a:xfrm>
           <a:prstGeom prst="rect">
@@ -2318,13 +2318,13 @@
             <a:r>
               <a:rPr lang="en-US" sz="720" b="1" dirty="0">
                 <a:solidFill>
-                  <a:srgbClr val="4B5F80"/>
-                </a:solidFill>
-                <a:latin typeface="Nunito" pitchFamily="34" charset="0"/>
-                <a:ea typeface="Nunito" pitchFamily="34" charset="-122"/>
-                <a:cs typeface="Nunito" pitchFamily="34" charset="-120"/>
-              </a:rPr>
-              <a:t>0.35x EBITDA</a:t>
+                  <a:srgbClr val="3BAF90"/>
+                </a:solidFill>
+                <a:latin typeface="Nunito" pitchFamily="34" charset="0"/>
+                <a:ea typeface="Nunito" pitchFamily="34" charset="-122"/>
+                <a:cs typeface="Nunito" pitchFamily="34" charset="-120"/>
+              </a:rPr>
+              <a:t>+25% vs. prior guide</a:t>
             </a:r>
             <a:endParaRPr lang="en-US" sz="720" dirty="0"/>
           </a:p>
@@ -2338,7 +2338,7 @@
         </p:nvSpPr>
         <p:spPr>
           <a:xfrm>
-            <a:off x="539496" y="4494225"/>
+            <a:off x="539496" y="4230827"/>
             <a:ext cx="6483096" cy="219456"/>
           </a:xfrm>
           <a:prstGeom prst="rect">
@@ -2363,7 +2363,7 @@
                 <a:ea typeface="Nunito" pitchFamily="34" charset="-122"/>
                 <a:cs typeface="Nunito" pitchFamily="34" charset="-120"/>
               </a:rPr>
-              <a:t>The debate moves from earnings to Brazil risk</a:t>
+              <a:t>The deal, not the quarter, drove the stock</a:t>
             </a:r>
             <a:endParaRPr lang="en-US" sz="1100" dirty="0"/>
           </a:p>
@@ -2377,7 +2377,7 @@
         </p:nvSpPr>
         <p:spPr>
           <a:xfrm>
-            <a:off x="539496" y="4741113"/>
+            <a:off x="539496" y="4477715"/>
             <a:ext cx="6483096" cy="645871"/>
           </a:xfrm>
           <a:prstGeom prst="rect">
@@ -2405,7 +2405,7 @@
                 <a:ea typeface="Nunito" pitchFamily="34" charset="-122"/>
                 <a:cs typeface="Nunito" pitchFamily="34" charset="-120"/>
               </a:rPr>
-              <a:t>Operationally, this was one of Galp’s strongest quarters: the Bacalhau field lifted production 14% and a refining margin of USD 34 per barrel, triple last year’s, drove a 25% guidance upgrade. The market looked past it. The shares fell 8.8% on results day as the end of the Moeve talks removed a catalyst and Brazil’s election-year fiscal noise raised the risk premium on its offshore assets. We think the price now discounts more than the lost deal.</a:t>
+              <a:t>The quarter was good: RCA (replacement cost adjusted) EBITDA beat consensus by 3.5% and full-year guidance rose 25%. The share price followed the deal: on results day Galp confirmed that ten months of talks to merge its Iberian refining and retail businesses with Moeve (formerly Cepsa) had ended without agreement. The shares fell 8.8%, about EUR 2.0 per share, close to twice the c.EUR 1.1 of synergy value analysts had assigned. The market is pricing a lost strategic option.</a:t>
             </a:r>
             <a:endParaRPr lang="en-US" sz="870" dirty="0"/>
           </a:p>
@@ -2419,7 +2419,7 @@
         </p:nvSpPr>
         <p:spPr>
           <a:xfrm>
-            <a:off x="539496" y="5466537"/>
+            <a:off x="539496" y="5203139"/>
             <a:ext cx="6483096" cy="182880"/>
           </a:xfrm>
           <a:prstGeom prst="rect">
@@ -2458,7 +2458,7 @@
                 <a:ea typeface="Nunito" pitchFamily="34" charset="-122"/>
                 <a:cs typeface="Nunito" pitchFamily="34" charset="-120"/>
               </a:rPr>
-              <a:t> · GALP: Q3 2026 RCA EBITDA vs. consensus and history</a:t>
+              <a:t> · GALP: results-day share price fall vs. lost synergy value</a:t>
             </a:r>
             <a:endParaRPr lang="en-US" sz="950" dirty="0"/>
           </a:p>
@@ -2472,7 +2472,7 @@
         </p:nvSpPr>
         <p:spPr>
           <a:xfrm>
-            <a:off x="539496" y="5649417"/>
+            <a:off x="539496" y="5386019"/>
             <a:ext cx="6483096" cy="118872"/>
           </a:xfrm>
           <a:prstGeom prst="rect">
@@ -2500,7 +2500,7 @@
                 <a:ea typeface="Nunito" pitchFamily="34" charset="-122"/>
                 <a:cs typeface="Nunito" pitchFamily="34" charset="-120"/>
               </a:rPr>
-              <a:t>EUR m · replacement cost adjusted (RCA) EBITDA, which strips out inventory gains and one-offs · consensus: pre-results analyst estimates</a:t>
+              <a:t>EUR per share · synergies: analyst estimates of EUR 750 to 800m · share price fall: 23 October close to the 26 October results-day print</a:t>
             </a:r>
             <a:endParaRPr lang="en-US" sz="720" dirty="0"/>
           </a:p>
@@ -2522,7 +2522,7 @@
         </p:blipFill>
         <p:spPr>
           <a:xfrm>
-            <a:off x="1641622" y="5814009"/>
+            <a:off x="1641622" y="5550611"/>
             <a:ext cx="4278843" cy="1334999"/>
           </a:xfrm>
           <a:prstGeom prst="rect">
@@ -2538,7 +2538,7 @@
         </p:nvSpPr>
         <p:spPr>
           <a:xfrm>
-            <a:off x="539496" y="7203872"/>
+            <a:off x="539496" y="6940474"/>
             <a:ext cx="6483096" cy="488975"/>
           </a:xfrm>
           <a:prstGeom prst="rect">
@@ -2566,7 +2566,7 @@
                 <a:ea typeface="Nunito" pitchFamily="34" charset="-122"/>
                 <a:cs typeface="Nunito" pitchFamily="34" charset="-120"/>
               </a:rPr>
-              <a:t>RCA EBITDA rose 67% year on year and 20% on the previous quarter to EUR 1,522m, 3.5% ahead of consensus. Upstream contributed EUR 708m and Industrial &amp; Midstream EUR 639m, double last year despite EUR 172m of refining hedge losses. Commercial grew 24% and Renewables tripled to EUR 48m. The beat came from volumes and margins, not one-offs.</a:t>
+              <a:t>The shares lost EUR 2.03 on results day, almost twice the c.EUR 1.1 of synergies analysts had assigned to the deal. We read the extra EUR 0.9 as the lost option to shrink Galp’s refining exposure: Galp would have kept only 20% of the combined refineries, moving it closer to an upstream growth story.</a:t>
             </a:r>
             <a:endParaRPr lang="en-US" sz="870" dirty="0"/>
           </a:p>
@@ -2580,7 +2580,7 @@
         </p:nvSpPr>
         <p:spPr>
           <a:xfrm>
-            <a:off x="539496" y="7808977"/>
+            <a:off x="539496" y="7545579"/>
             <a:ext cx="6483096" cy="219456"/>
           </a:xfrm>
           <a:prstGeom prst="rect">
@@ -2619,7 +2619,7 @@
         </p:nvSpPr>
         <p:spPr>
           <a:xfrm>
-            <a:off x="539496" y="8055865"/>
+            <a:off x="539496" y="7792467"/>
             <a:ext cx="6483096" cy="802767"/>
           </a:xfrm>
           <a:prstGeom prst="rect">
@@ -2647,7 +2647,7 @@
                 <a:ea typeface="Nunito" pitchFamily="34" charset="-122"/>
                 <a:cs typeface="Nunito" pitchFamily="34" charset="-120"/>
               </a:rPr>
-              <a:t>We stay positive on Galp and would use the results-day weakness to add, sized for Brazil political risk. We underwrite the new 2026 guidance of c.EUR 5bn EBITDA and c.EUR 3.9bn operating cash flow, with net debt at 0.35x EBITDA funding a proposed 10% dividend increase to EUR 0.70 and the EUR 250m buyback. The debate is now how much of those earnings Brazil keeps. The 8.8% drop, about EUR 2.0 per share, already exceeds the c.EUR 1.1 of deal value the market had assigned. The next test is Brazil’s post-election stance on the oil export tax.</a:t>
+              <a:t>We stay positive on Galp and would add on the results-day weakness. The sell-off prices the failed merger as a permanent loss of value, too harshly in our view: the synergies were worth about EUR 1.1 per share, the shares lost EUR 2.0, and Galp keeps a standalone downstream that earned EUR 639m of EBITDA in Q3. We underwrite the new c.EUR 5bn EBITDA and c.EUR 3.9bn cash flow guidance, with a proposed 10% dividend rise to EUR 0.70 and the EUR 250m buyback. Management still backs consolidation; the next test is whether it sets out another route for downstream at full-year results.</a:t>
             </a:r>
             <a:endParaRPr lang="en-US" sz="870" dirty="0"/>
           </a:p>
@@ -2661,7 +2661,7 @@
         </p:nvSpPr>
         <p:spPr>
           <a:xfrm>
-            <a:off x="3781044" y="8974760"/>
+            <a:off x="3781044" y="8711362"/>
             <a:ext cx="0" cy="985647"/>
           </a:xfrm>
           <a:prstGeom prst="line">
@@ -2684,7 +2684,7 @@
         </p:nvSpPr>
         <p:spPr>
           <a:xfrm>
-            <a:off x="539496" y="8974760"/>
+            <a:off x="539496" y="8711362"/>
             <a:ext cx="3058668" cy="155448"/>
           </a:xfrm>
           <a:prstGeom prst="rect">
@@ -2723,8 +2723,8 @@
         </p:nvSpPr>
         <p:spPr>
           <a:xfrm>
-            <a:off x="539496" y="9166784"/>
-            <a:ext cx="3058668" cy="784479"/>
+            <a:off x="539496" y="8903386"/>
+            <a:ext cx="3058668" cy="627583"/>
           </a:xfrm>
           <a:prstGeom prst="rect">
             <a:avLst/>
@@ -2751,7 +2751,7 @@
                 <a:ea typeface="Nunito" pitchFamily="34" charset="-122"/>
                 <a:cs typeface="Nunito" pitchFamily="34" charset="-120"/>
               </a:rPr>
-              <a:t>Brazil lets the temporary oil export tax lapse after the run-off; Bacalhau holds about 160,000 barrels a day gross through the fourth quarter; Q4 EBITDA beats the c.EUR 1.26bn implied by guidance; a larger 2027 buyback at full-year results.</a:t>
+              <a:t>A new route for downstream at full-year results, such as a Sines partner or a smaller retail deal; Moeve or another party returns on revised terms; Q4 EBITDA beats the c.EUR 1.26bn implied by guidance; a larger 2027 buyback.</a:t>
             </a:r>
             <a:endParaRPr lang="en-US" sz="870" dirty="0"/>
           </a:p>
@@ -2765,7 +2765,7 @@
         </p:nvSpPr>
         <p:spPr>
           <a:xfrm>
-            <a:off x="3963924" y="8974760"/>
+            <a:off x="3963924" y="8711362"/>
             <a:ext cx="3058668" cy="155448"/>
           </a:xfrm>
           <a:prstGeom prst="rect">
@@ -2804,7 +2804,7 @@
         </p:nvSpPr>
         <p:spPr>
           <a:xfrm>
-            <a:off x="3963924" y="9166784"/>
+            <a:off x="3963924" y="8903386"/>
             <a:ext cx="3058668" cy="784479"/>
           </a:xfrm>
           <a:prstGeom prst="rect">
@@ -2832,7 +2832,7 @@
                 <a:ea typeface="Nunito" pitchFamily="34" charset="-122"/>
                 <a:cs typeface="Nunito" pitchFamily="34" charset="-120"/>
               </a:rPr>
-              <a:t>The export tax becomes permanent or is raised above 12%, or royalties are reopened under a resource-nationalism agenda; refining margins fall back towards the USD 13 per barrel of the original guidance; capital is redirected into a large, dilutive acquisition after Moeve.</a:t>
+              <a:t>Galp turns buyer and raises its refining exposure through a large acquisition; refining margins fall back towards the USD 13 per barrel of the original guidance, cutting the value of the standalone business; Brazil makes its temporary oil export tax permanent.</a:t>
             </a:r>
             <a:endParaRPr lang="en-US" sz="870" dirty="0"/>
           </a:p>
@@ -3110,7 +3110,7 @@
                 <a:ea typeface="Nunito" pitchFamily="34" charset="-122"/>
                 <a:cs typeface="Nunito" pitchFamily="34" charset="-120"/>
               </a:rPr>
-              <a:t>Upstream RCA EBITDA rose 53% to EUR 708m. Working-interest production averaged 131 kboe/d, up 14%, as the Bacalhau FPSO ramped up with four producer wells connected, reaching about 160 kboe/d gross in September and more than offsetting planned turnarounds. Oil realisations rose 32% to USD 87.3/bbl, although the discount to Brent widened to USD 9.7/bbl on freight and softer Asian demand for Brazilian crude. Industrial &amp; Midstream EBITDA doubled to EUR 639m: the refining margin reached USD 34.0/boe against USD 9.5/boe a year ago, on diesel cracks of USD 590/t, with Sines running close to full availability. Margin hedges cost EUR 172m and supply pricing-formula lags a further EUR 125m.</a:t>
+              <a:t>RCA EBITDA rose 67% to EUR 1,522m. Upstream gained 53% to EUR 708m as the Bacalhau FPSO lifted working-interest production 14% to 131 kboe/d, with oil realisations up 32% to USD 87.3/bbl. Industrial &amp; Midstream doubled to EUR 639m: the refining margin reached USD 34.0/boe against USD 9.5/boe a year ago, on diesel cracks of USD 590/t, despite EUR 172m of hedge losses and EUR 125m of pricing-formula lags. Commercial rose 24% to EUR 147m and Renewables tripled to EUR 48m. RCA net income rose 68% to EUR 682m, about EUR 0.94 per share on our count, and operating cash flow of EUR 1,223m (+63%) left net debt at EUR 1.43bn, or 0.35x EBITDA.</a:t>
             </a:r>
             <a:endParaRPr lang="en-US" sz="870" dirty="0"/>
           </a:p>
@@ -3152,7 +3152,7 @@
                 <a:ea typeface="Nunito" pitchFamily="34" charset="-122"/>
                 <a:cs typeface="Nunito" pitchFamily="34" charset="-120"/>
               </a:rPr>
-              <a:t>Commercial EBITDA rose 24% to EUR 147m on B2B sales in Spain; Renewables tripled to EUR 48m on newly acquired wind assets. RCA net income of EUR 682m, about EUR 0.94 per share on our count, rose 68% despite RCA taxes up 79% to EUR 493m, which include Brazil’s temporary oil export tax. IFRS net income was EUR 201m after EUR 453m of special items, mostly derivative mark-to-market. Operating cash flow of EUR 1,223m (+63%) covered EUR 646m of capex, including EUR 420m for Spanish wind, and the EUR 253m interim dividend, leaving net debt at EUR 1.43bn.</a:t>
+              <a:t>Management raised 2026 RCA EBITDA guidance to c.EUR 5bn from c.EUR 4bn and operating cash flow to c.EUR 3.9bn from c.EUR 3bn, on Brent at USD 90/bbl (from 80) and a realised refining margin of c.USD 25/boe (from 13). The guide implies Q4 EBITDA of about EUR 1.26bn and, on our arithmetic, a Q4 Brent near USD 78/bbl against USD 97 in Q3, so oil leaves room for a beat. Two items temper the read-across: the Sines hydrocracker turnaround that began in late September, and Brazil’s temporary oil export tax, which lifted RCA taxes 79% to EUR 493m.</a:t>
             </a:r>
             <a:endParaRPr lang="en-US" sz="870" dirty="0"/>
           </a:p>
@@ -3191,7 +3191,7 @@
                 <a:ea typeface="Nunito" pitchFamily="34" charset="-122"/>
                 <a:cs typeface="Nunito" pitchFamily="34" charset="-120"/>
               </a:rPr>
-              <a:t>Outlook: the upgrade leans on the macro deck</a:t>
+              <a:t>The deal: a valuation gap at peak margins</a:t>
             </a:r>
             <a:endParaRPr lang="en-US" sz="1100" dirty="0"/>
           </a:p>
@@ -3206,7 +3206,7 @@
         <p:spPr>
           <a:xfrm>
             <a:off x="539496" y="3636035"/>
-            <a:ext cx="6483096" cy="802767"/>
+            <a:ext cx="6483096" cy="959663"/>
           </a:xfrm>
           <a:prstGeom prst="rect">
             <a:avLst/>
@@ -3233,7 +3233,7 @@
                 <a:ea typeface="Nunito" pitchFamily="34" charset="-122"/>
                 <a:cs typeface="Nunito" pitchFamily="34" charset="-120"/>
               </a:rPr>
-              <a:t>Management raised 2026 RCA EBITDA guidance to c.EUR 5bn from c.EUR 4bn and operating cash flow to c.EUR 3.9bn from c.EUR 3bn, on Brent at USD 90/bbl (from 80) and a realised refining margin of c.USD 25/boe (from 13). The guide implies Q4 EBITDA of about EUR 1.26bn and, on our arithmetic, a Q4 Brent near USD 78/bbl against USD 97 in Q3. The risk sits in Brazil: the temporary 12% crude export tax costs up to EUR 100m, and the polarised run-off widened the risk premium on pre-salt assets, which in our view complicated valuation talks with Moeve’s shareholders.</a:t>
+              <a:t>Announced in January, the plan would have created two Iberian platforms: a 50/50 RetailCo with about 3,500 service stations, and an IndustrialCo holding the Huelva, Cádiz and Sines refineries, 80% owned by Moeve and 20% by Galp. Talks failed on valuation. With refining margins high but volatile, the sides could not agree what the refineries were worth, and Q3’s EUR 639m of Industrial EBITDA shows why Galp would not sell at a discount. Handing Sines, Portugal’s only refinery, to a platform controlled by Mubadala and Carlyle also raised energy-security concerns, and press reports say the Amorim family, Galp’s largest shareholder, rejected some of Moeve’s demands.</a:t>
             </a:r>
             <a:endParaRPr lang="en-US" sz="870" dirty="0"/>
           </a:p>
@@ -3247,7 +3247,7 @@
         </p:nvSpPr>
         <p:spPr>
           <a:xfrm>
-            <a:off x="539496" y="4554931"/>
+            <a:off x="539496" y="4711827"/>
             <a:ext cx="6483096" cy="219456"/>
           </a:xfrm>
           <a:prstGeom prst="rect">
@@ -3286,7 +3286,7 @@
         </p:nvSpPr>
         <p:spPr>
           <a:xfrm>
-            <a:off x="539496" y="4801819"/>
+            <a:off x="539496" y="4958715"/>
             <a:ext cx="6483096" cy="182880"/>
           </a:xfrm>
           <a:prstGeom prst="rect">
@@ -3339,7 +3339,7 @@
         </p:nvSpPr>
         <p:spPr>
           <a:xfrm>
-            <a:off x="539496" y="4984699"/>
+            <a:off x="539496" y="5141595"/>
             <a:ext cx="6483096" cy="237744"/>
           </a:xfrm>
           <a:prstGeom prst="rect">
@@ -3389,7 +3389,7 @@
         </p:blipFill>
         <p:spPr>
           <a:xfrm>
-            <a:off x="928482" y="5268163"/>
+            <a:off x="928482" y="5425059"/>
             <a:ext cx="5705124" cy="3413946"/>
           </a:xfrm>
           <a:prstGeom prst="rect">
@@ -3405,8 +3405,8 @@
         </p:nvSpPr>
         <p:spPr>
           <a:xfrm>
-            <a:off x="539496" y="8736974"/>
-            <a:ext cx="6483096" cy="802767"/>
+            <a:off x="539496" y="8893869"/>
+            <a:ext cx="6483096" cy="645871"/>
           </a:xfrm>
           <a:prstGeom prst="rect">
             <a:avLst/>
@@ -3433,7 +3433,7 @@
                 <a:ea typeface="Nunito" pitchFamily="34" charset="-122"/>
                 <a:cs typeface="Nunito" pitchFamily="34" charset="-120"/>
               </a:rPr>
-              <a:t>Earnings have run well ahead of the share price. Over 12 months, consensus 12m-forward EPS rose 87% to EUR 2.48 while the price gained 24%, so the forward P/E fell from 12.7x to 8.4x, 27% below its 11.6x average since 2022 and under the 10.9x one-year average; results day alone took it down from 9.2x. The price is 10% below its September high of EUR 23.18 but still 6% above its 40-week average. Even if consensus EPS were cut 10% for the export tax, the stock would trade on 9.4x, 19% below its 2022 to 2026 average.</a:t>
+              <a:t>Earnings have run well ahead of the share price. Over 12 months, consensus 12m-forward EPS rose 87% to EUR 2.48 while the price gained 24%, so the forward P/E fell from 12.7x to 8.4x, 27% below its 11.6x average since 2022 and under the 10.9x one-year average; results day alone took it down from 9.2x. Removing the full EUR 1.1 of synergy value from the pre-results EUR 22.96 would leave EUR 21.86, or 8.8x: the stock now trades below that, though still 6% above its 40-week average.</a:t>
             </a:r>
             <a:endParaRPr lang="en-US" sz="870" dirty="0"/>
           </a:p>
@@ -3644,7 +3644,7 @@
                 <a:ea typeface="Nunito" pitchFamily="34" charset="-122"/>
                 <a:cs typeface="Nunito" pitchFamily="34" charset="-120"/>
               </a:rPr>
-              <a:t> Source: Syz Research, Bloomberg, company filings, Galp Q3 2026 results release of 26 October 2026, analyst research notes of 23 October 2026</a:t>
+              <a:t> Source: Syz Research, Bloomberg, company filings, Galp Q3 2026 results release of 26 October 2026, analyst research notes, press reports of October 2026</a:t>
             </a:r>
             <a:endParaRPr lang="en-US" sz="680" dirty="0"/>
           </a:p>

</xml_diff>

<commit_message>
Galp Q3 2026: add a Brazil election section, apply user text edits
- Page 2: new section 'Brazil: the election adds a risk premium' (export tax,
  run-off, sovereign risk premium); export-tax detail moved out of the guidance
  paragraph to avoid repetition
- User edits from the reviewed deck: kicker without sector, new title, base
  case without the add-on-weakness clause
- build_pdf.py / build_pptx.js: optional third page-2 section and kicker
  without theme; Chart 2 at W2 82 (PDF) / 80 (PPTX) to keep three pages

Co-Authored-By: Claude Opus 5.5 <noreply@anthropic.com>
Claude-Session: https://claude.ai/code/session_01GhQ2PLYzYFZ38n9VawGH3T
</commit_message>
<xml_diff>
--- a/outputs/GALP_Q3_2026/Earnings_Update_GALP_Q32026.pptx
+++ b/outputs/GALP_Q3_2026/Earnings_Update_GALP_Q32026.pptx
@@ -1212,7 +1212,7 @@
                 <a:ea typeface="Nunito" pitchFamily="34" charset="-122"/>
                 <a:cs typeface="Nunito" pitchFamily="34" charset="-120"/>
               </a:rPr>
-              <a:t>Earnings update · Integrated oil and gas</a:t>
+              <a:t>Earnings update</a:t>
             </a:r>
             <a:endParaRPr lang="en-US" sz="800" dirty="0"/>
           </a:p>
@@ -1227,7 +1227,7 @@
         <p:spPr>
           <a:xfrm>
             <a:off x="539496" y="1028700"/>
-            <a:ext cx="6483096" cy="263398"/>
+            <a:ext cx="6483096" cy="526796"/>
           </a:xfrm>
           <a:prstGeom prst="rect">
             <a:avLst/>
@@ -1254,7 +1254,7 @@
                 <a:ea typeface="Nunito" pitchFamily="34" charset="-122"/>
                 <a:cs typeface="Nunito" pitchFamily="34" charset="-120"/>
               </a:rPr>
-              <a:t>Galp Q3 2026: Moeve collapse hits the stock, not the case</a:t>
+              <a:t>Galp Q3 2026: guidance raised, deal off, the sell-off goes too far</a:t>
             </a:r>
             <a:endParaRPr lang="en-US" sz="1700" dirty="0"/>
           </a:p>
@@ -1268,7 +1268,7 @@
         </p:nvSpPr>
         <p:spPr>
           <a:xfrm>
-            <a:off x="539496" y="1328674"/>
+            <a:off x="539496" y="1592072"/>
             <a:ext cx="6483096" cy="164592"/>
           </a:xfrm>
           <a:prstGeom prst="rect">
@@ -1307,7 +1307,7 @@
         </p:nvSpPr>
         <p:spPr>
           <a:xfrm>
-            <a:off x="539496" y="1612138"/>
+            <a:off x="539496" y="1875536"/>
             <a:ext cx="42977" cy="573786"/>
           </a:xfrm>
           <a:prstGeom prst="rect">
@@ -1332,7 +1332,7 @@
         </p:nvSpPr>
         <p:spPr>
           <a:xfrm>
-            <a:off x="722376" y="1630426"/>
+            <a:off x="722376" y="1893824"/>
             <a:ext cx="6300216" cy="336042"/>
           </a:xfrm>
           <a:prstGeom prst="rect">
@@ -1374,7 +1374,7 @@
         </p:nvSpPr>
         <p:spPr>
           <a:xfrm>
-            <a:off x="722376" y="2003044"/>
+            <a:off x="722376" y="2266442"/>
             <a:ext cx="6300216" cy="155448"/>
           </a:xfrm>
           <a:prstGeom prst="rect">
@@ -1413,7 +1413,7 @@
         </p:nvSpPr>
         <p:spPr>
           <a:xfrm>
-            <a:off x="539496" y="2304796"/>
+            <a:off x="539496" y="2568194"/>
             <a:ext cx="6483096" cy="219456"/>
           </a:xfrm>
           <a:prstGeom prst="rect">
@@ -1452,7 +1452,7 @@
         </p:nvSpPr>
         <p:spPr>
           <a:xfrm>
-            <a:off x="539496" y="2565400"/>
+            <a:off x="539496" y="2828798"/>
             <a:ext cx="576072" cy="156896"/>
           </a:xfrm>
           <a:prstGeom prst="rect">
@@ -1491,7 +1491,7 @@
         </p:nvSpPr>
         <p:spPr>
           <a:xfrm>
-            <a:off x="1133856" y="2542540"/>
+            <a:off x="1133856" y="2805938"/>
             <a:ext cx="5888736" cy="156896"/>
           </a:xfrm>
           <a:prstGeom prst="rect">
@@ -1533,7 +1533,7 @@
         </p:nvSpPr>
         <p:spPr>
           <a:xfrm>
-            <a:off x="539496" y="2768016"/>
+            <a:off x="539496" y="3031414"/>
             <a:ext cx="576072" cy="156896"/>
           </a:xfrm>
           <a:prstGeom prst="rect">
@@ -1572,7 +1572,7 @@
         </p:nvSpPr>
         <p:spPr>
           <a:xfrm>
-            <a:off x="1133856" y="2745156"/>
+            <a:off x="1133856" y="3008554"/>
             <a:ext cx="5888736" cy="156896"/>
           </a:xfrm>
           <a:prstGeom prst="rect">
@@ -1614,7 +1614,7 @@
         </p:nvSpPr>
         <p:spPr>
           <a:xfrm>
-            <a:off x="539496" y="2970632"/>
+            <a:off x="539496" y="3234030"/>
             <a:ext cx="576072" cy="156896"/>
           </a:xfrm>
           <a:prstGeom prst="rect">
@@ -1653,7 +1653,7 @@
         </p:nvSpPr>
         <p:spPr>
           <a:xfrm>
-            <a:off x="1133856" y="2947772"/>
+            <a:off x="1133856" y="3211170"/>
             <a:ext cx="5888736" cy="156896"/>
           </a:xfrm>
           <a:prstGeom prst="rect">
@@ -1695,7 +1695,7 @@
         </p:nvSpPr>
         <p:spPr>
           <a:xfrm>
-            <a:off x="539496" y="3173247"/>
+            <a:off x="539496" y="3436645"/>
             <a:ext cx="576072" cy="156896"/>
           </a:xfrm>
           <a:prstGeom prst="rect">
@@ -1734,7 +1734,7 @@
         </p:nvSpPr>
         <p:spPr>
           <a:xfrm>
-            <a:off x="1133856" y="3150387"/>
+            <a:off x="1133856" y="3413785"/>
             <a:ext cx="5888736" cy="156896"/>
           </a:xfrm>
           <a:prstGeom prst="rect">
@@ -1776,7 +1776,7 @@
         </p:nvSpPr>
         <p:spPr>
           <a:xfrm>
-            <a:off x="539496" y="3435299"/>
+            <a:off x="539496" y="3698697"/>
             <a:ext cx="6483096" cy="676656"/>
           </a:xfrm>
           <a:prstGeom prst="rect">
@@ -1801,7 +1801,7 @@
         </p:nvSpPr>
         <p:spPr>
           <a:xfrm>
-            <a:off x="649224" y="3517595"/>
+            <a:off x="649224" y="3780993"/>
             <a:ext cx="1437894" cy="146304"/>
           </a:xfrm>
           <a:prstGeom prst="rect">
@@ -1840,7 +1840,7 @@
         </p:nvSpPr>
         <p:spPr>
           <a:xfrm>
-            <a:off x="649224" y="3663899"/>
+            <a:off x="649224" y="3927297"/>
             <a:ext cx="1437894" cy="237744"/>
           </a:xfrm>
           <a:prstGeom prst="rect">
@@ -1879,7 +1879,7 @@
         </p:nvSpPr>
         <p:spPr>
           <a:xfrm>
-            <a:off x="649224" y="3901643"/>
+            <a:off x="649224" y="4165041"/>
             <a:ext cx="1437894" cy="146304"/>
           </a:xfrm>
           <a:prstGeom prst="rect">
@@ -1918,7 +1918,7 @@
         </p:nvSpPr>
         <p:spPr>
           <a:xfrm>
-            <a:off x="2160270" y="3435299"/>
+            <a:off x="2160270" y="3698697"/>
             <a:ext cx="0" cy="676656"/>
           </a:xfrm>
           <a:prstGeom prst="line">
@@ -1941,7 +1941,7 @@
         </p:nvSpPr>
         <p:spPr>
           <a:xfrm>
-            <a:off x="2269998" y="3517595"/>
+            <a:off x="2269998" y="3780993"/>
             <a:ext cx="1437894" cy="146304"/>
           </a:xfrm>
           <a:prstGeom prst="rect">
@@ -1980,7 +1980,7 @@
         </p:nvSpPr>
         <p:spPr>
           <a:xfrm>
-            <a:off x="2269998" y="3663899"/>
+            <a:off x="2269998" y="3927297"/>
             <a:ext cx="1437894" cy="237744"/>
           </a:xfrm>
           <a:prstGeom prst="rect">
@@ -2019,7 +2019,7 @@
         </p:nvSpPr>
         <p:spPr>
           <a:xfrm>
-            <a:off x="2269998" y="3901643"/>
+            <a:off x="2269998" y="4165041"/>
             <a:ext cx="1437894" cy="146304"/>
           </a:xfrm>
           <a:prstGeom prst="rect">
@@ -2058,7 +2058,7 @@
         </p:nvSpPr>
         <p:spPr>
           <a:xfrm>
-            <a:off x="3781044" y="3435299"/>
+            <a:off x="3781044" y="3698697"/>
             <a:ext cx="0" cy="676656"/>
           </a:xfrm>
           <a:prstGeom prst="line">
@@ -2081,7 +2081,7 @@
         </p:nvSpPr>
         <p:spPr>
           <a:xfrm>
-            <a:off x="3890772" y="3517595"/>
+            <a:off x="3890772" y="3780993"/>
             <a:ext cx="1437894" cy="146304"/>
           </a:xfrm>
           <a:prstGeom prst="rect">
@@ -2120,7 +2120,7 @@
         </p:nvSpPr>
         <p:spPr>
           <a:xfrm>
-            <a:off x="3890772" y="3663899"/>
+            <a:off x="3890772" y="3927297"/>
             <a:ext cx="1437894" cy="237744"/>
           </a:xfrm>
           <a:prstGeom prst="rect">
@@ -2159,7 +2159,7 @@
         </p:nvSpPr>
         <p:spPr>
           <a:xfrm>
-            <a:off x="3890772" y="3901643"/>
+            <a:off x="3890772" y="4165041"/>
             <a:ext cx="1437894" cy="146304"/>
           </a:xfrm>
           <a:prstGeom prst="rect">
@@ -2198,7 +2198,7 @@
         </p:nvSpPr>
         <p:spPr>
           <a:xfrm>
-            <a:off x="5401818" y="3435299"/>
+            <a:off x="5401818" y="3698697"/>
             <a:ext cx="0" cy="676656"/>
           </a:xfrm>
           <a:prstGeom prst="line">
@@ -2221,7 +2221,7 @@
         </p:nvSpPr>
         <p:spPr>
           <a:xfrm>
-            <a:off x="5511546" y="3517595"/>
+            <a:off x="5511546" y="3780993"/>
             <a:ext cx="1437894" cy="146304"/>
           </a:xfrm>
           <a:prstGeom prst="rect">
@@ -2260,7 +2260,7 @@
         </p:nvSpPr>
         <p:spPr>
           <a:xfrm>
-            <a:off x="5511546" y="3663899"/>
+            <a:off x="5511546" y="3927297"/>
             <a:ext cx="1437894" cy="237744"/>
           </a:xfrm>
           <a:prstGeom prst="rect">
@@ -2299,7 +2299,7 @@
         </p:nvSpPr>
         <p:spPr>
           <a:xfrm>
-            <a:off x="5511546" y="3901643"/>
+            <a:off x="5511546" y="4165041"/>
             <a:ext cx="1437894" cy="146304"/>
           </a:xfrm>
           <a:prstGeom prst="rect">
@@ -2338,7 +2338,7 @@
         </p:nvSpPr>
         <p:spPr>
           <a:xfrm>
-            <a:off x="539496" y="4230827"/>
+            <a:off x="539496" y="4494225"/>
             <a:ext cx="6483096" cy="219456"/>
           </a:xfrm>
           <a:prstGeom prst="rect">
@@ -2377,7 +2377,7 @@
         </p:nvSpPr>
         <p:spPr>
           <a:xfrm>
-            <a:off x="539496" y="4477715"/>
+            <a:off x="539496" y="4741113"/>
             <a:ext cx="6483096" cy="645871"/>
           </a:xfrm>
           <a:prstGeom prst="rect">
@@ -2419,7 +2419,7 @@
         </p:nvSpPr>
         <p:spPr>
           <a:xfrm>
-            <a:off x="539496" y="5203139"/>
+            <a:off x="539496" y="5466537"/>
             <a:ext cx="6483096" cy="182880"/>
           </a:xfrm>
           <a:prstGeom prst="rect">
@@ -2472,7 +2472,7 @@
         </p:nvSpPr>
         <p:spPr>
           <a:xfrm>
-            <a:off x="539496" y="5386019"/>
+            <a:off x="539496" y="5649417"/>
             <a:ext cx="6483096" cy="118872"/>
           </a:xfrm>
           <a:prstGeom prst="rect">
@@ -2522,7 +2522,7 @@
         </p:blipFill>
         <p:spPr>
           <a:xfrm>
-            <a:off x="1641622" y="5550611"/>
+            <a:off x="1641622" y="5814009"/>
             <a:ext cx="4278843" cy="1334999"/>
           </a:xfrm>
           <a:prstGeom prst="rect">
@@ -2538,7 +2538,7 @@
         </p:nvSpPr>
         <p:spPr>
           <a:xfrm>
-            <a:off x="539496" y="6940474"/>
+            <a:off x="539496" y="7203872"/>
             <a:ext cx="6483096" cy="488975"/>
           </a:xfrm>
           <a:prstGeom prst="rect">
@@ -2580,7 +2580,7 @@
         </p:nvSpPr>
         <p:spPr>
           <a:xfrm>
-            <a:off x="539496" y="7545579"/>
+            <a:off x="539496" y="7808977"/>
             <a:ext cx="6483096" cy="219456"/>
           </a:xfrm>
           <a:prstGeom prst="rect">
@@ -2619,7 +2619,7 @@
         </p:nvSpPr>
         <p:spPr>
           <a:xfrm>
-            <a:off x="539496" y="7792467"/>
+            <a:off x="539496" y="8055865"/>
             <a:ext cx="6483096" cy="802767"/>
           </a:xfrm>
           <a:prstGeom prst="rect">
@@ -2647,7 +2647,7 @@
                 <a:ea typeface="Nunito" pitchFamily="34" charset="-122"/>
                 <a:cs typeface="Nunito" pitchFamily="34" charset="-120"/>
               </a:rPr>
-              <a:t>We stay positive on Galp and would add on the results-day weakness. The sell-off prices the failed merger as a permanent loss of value, too harshly in our view: the synergies were worth about EUR 1.1 per share, the shares lost EUR 2.0, and Galp keeps a standalone downstream that earned EUR 639m of EBITDA in Q3. We underwrite the new c.EUR 5bn EBITDA and c.EUR 3.9bn cash flow guidance, with a proposed 10% dividend rise to EUR 0.70 and the EUR 250m buyback. Management still backs consolidation; the next test is whether it sets out another route for downstream at full-year results.</a:t>
+              <a:t>We stay positive on Galp. The sell-off prices the failed merger as a permanent loss of value, too harshly in our view: the synergies were worth about EUR 1.1 per share, the shares lost EUR 2.0, and Galp keeps a standalone downstream that earned EUR 639m of EBITDA in Q3. We underwrite the new c.EUR 5bn EBITDA and c.EUR 3.9bn cash flow guidance, with a proposed 10% dividend rise to EUR 0.70 and the EUR 250m buyback. Management still backs consolidation; the next test is whether it sets out another route for downstream at full-year results.</a:t>
             </a:r>
             <a:endParaRPr lang="en-US" sz="870" dirty="0"/>
           </a:p>
@@ -2661,7 +2661,7 @@
         </p:nvSpPr>
         <p:spPr>
           <a:xfrm>
-            <a:off x="3781044" y="8711362"/>
+            <a:off x="3781044" y="8974760"/>
             <a:ext cx="0" cy="985647"/>
           </a:xfrm>
           <a:prstGeom prst="line">
@@ -2684,7 +2684,7 @@
         </p:nvSpPr>
         <p:spPr>
           <a:xfrm>
-            <a:off x="539496" y="8711362"/>
+            <a:off x="539496" y="8974760"/>
             <a:ext cx="3058668" cy="155448"/>
           </a:xfrm>
           <a:prstGeom prst="rect">
@@ -2723,7 +2723,7 @@
         </p:nvSpPr>
         <p:spPr>
           <a:xfrm>
-            <a:off x="539496" y="8903386"/>
+            <a:off x="539496" y="9166784"/>
             <a:ext cx="3058668" cy="627583"/>
           </a:xfrm>
           <a:prstGeom prst="rect">
@@ -2765,7 +2765,7 @@
         </p:nvSpPr>
         <p:spPr>
           <a:xfrm>
-            <a:off x="3963924" y="8711362"/>
+            <a:off x="3963924" y="8974760"/>
             <a:ext cx="3058668" cy="155448"/>
           </a:xfrm>
           <a:prstGeom prst="rect">
@@ -2804,7 +2804,7 @@
         </p:nvSpPr>
         <p:spPr>
           <a:xfrm>
-            <a:off x="3963924" y="8903386"/>
+            <a:off x="3963924" y="9166784"/>
             <a:ext cx="3058668" cy="784479"/>
           </a:xfrm>
           <a:prstGeom prst="rect">
@@ -3083,7 +3083,7 @@
         <p:spPr>
           <a:xfrm>
             <a:off x="539496" y="1431036"/>
-            <a:ext cx="6483096" cy="959663"/>
+            <a:ext cx="6483096" cy="802767"/>
           </a:xfrm>
           <a:prstGeom prst="rect">
             <a:avLst/>
@@ -3110,7 +3110,7 @@
                 <a:ea typeface="Nunito" pitchFamily="34" charset="-122"/>
                 <a:cs typeface="Nunito" pitchFamily="34" charset="-120"/>
               </a:rPr>
-              <a:t>RCA EBITDA rose 67% to EUR 1,522m. Upstream gained 53% to EUR 708m as the Bacalhau FPSO lifted working-interest production 14% to 131 kboe/d, with oil realisations up 32% to USD 87.3/bbl. Industrial &amp; Midstream doubled to EUR 639m: the refining margin reached USD 34.0/boe against USD 9.5/boe a year ago, on diesel cracks of USD 590/t, despite EUR 172m of hedge losses and EUR 125m of pricing-formula lags. Commercial rose 24% to EUR 147m and Renewables tripled to EUR 48m. RCA net income rose 68% to EUR 682m, about EUR 0.94 per share on our count, and operating cash flow of EUR 1,223m (+63%) left net debt at EUR 1.43bn, or 0.35x EBITDA.</a:t>
+              <a:t>RCA EBITDA rose 67% to EUR 1,522m. Upstream gained 53% to EUR 708m as the Bacalhau FPSO lifted working-interest production 14% to 131 kboe/d. Industrial &amp; Midstream doubled to EUR 639m: the refining margin reached USD 34.0/boe against USD 9.5/boe a year ago, on diesel cracks of USD 590/t, despite EUR 172m of hedge losses and EUR 125m of pricing-formula lags. Commercial rose 24% to EUR 147m and Renewables tripled to EUR 48m. RCA net income rose 68% to EUR 682m, about EUR 0.94 per share on our count, and operating cash flow of EUR 1,223m (+63%) left net debt at EUR 1.43bn.</a:t>
             </a:r>
             <a:endParaRPr lang="en-US" sz="870" dirty="0"/>
           </a:p>
@@ -3124,8 +3124,8 @@
         </p:nvSpPr>
         <p:spPr>
           <a:xfrm>
-            <a:off x="539496" y="2470252"/>
-            <a:ext cx="6483096" cy="802767"/>
+            <a:off x="539496" y="2313356"/>
+            <a:ext cx="6483096" cy="645871"/>
           </a:xfrm>
           <a:prstGeom prst="rect">
             <a:avLst/>
@@ -3152,7 +3152,7 @@
                 <a:ea typeface="Nunito" pitchFamily="34" charset="-122"/>
                 <a:cs typeface="Nunito" pitchFamily="34" charset="-120"/>
               </a:rPr>
-              <a:t>Management raised 2026 RCA EBITDA guidance to c.EUR 5bn from c.EUR 4bn and operating cash flow to c.EUR 3.9bn from c.EUR 3bn, on Brent at USD 90/bbl (from 80) and a realised refining margin of c.USD 25/boe (from 13). The guide implies Q4 EBITDA of about EUR 1.26bn and, on our arithmetic, a Q4 Brent near USD 78/bbl against USD 97 in Q3, so oil leaves room for a beat. Two items temper the read-across: the Sines hydrocracker turnaround that began in late September, and Brazil’s temporary oil export tax, which lifted RCA taxes 79% to EUR 493m.</a:t>
+              <a:t>Management raised 2026 RCA EBITDA guidance to c.EUR 5bn from c.EUR 4bn and operating cash flow to c.EUR 3.9bn from c.EUR 3bn, on Brent at USD 90/bbl (from 80) and a realised refining margin of c.USD 25/boe (from 13). The guide implies Q4 EBITDA of about EUR 1.26bn and, on our arithmetic, a Q4 Brent near USD 78/bbl against USD 97 in Q3, so oil leaves room for a beat. The Sines hydrocracker turnaround that began in late September is the main Q4 swing factor.</a:t>
             </a:r>
             <a:endParaRPr lang="en-US" sz="870" dirty="0"/>
           </a:p>
@@ -3166,7 +3166,7 @@
         </p:nvSpPr>
         <p:spPr>
           <a:xfrm>
-            <a:off x="539496" y="3389147"/>
+            <a:off x="539496" y="3075356"/>
             <a:ext cx="6483096" cy="219456"/>
           </a:xfrm>
           <a:prstGeom prst="rect">
@@ -3205,7 +3205,7 @@
         </p:nvSpPr>
         <p:spPr>
           <a:xfrm>
-            <a:off x="539496" y="3636035"/>
+            <a:off x="539496" y="3322244"/>
             <a:ext cx="6483096" cy="959663"/>
           </a:xfrm>
           <a:prstGeom prst="rect">
@@ -3233,7 +3233,7 @@
                 <a:ea typeface="Nunito" pitchFamily="34" charset="-122"/>
                 <a:cs typeface="Nunito" pitchFamily="34" charset="-120"/>
               </a:rPr>
-              <a:t>Announced in January, the plan would have created two Iberian platforms: a 50/50 RetailCo with about 3,500 service stations, and an IndustrialCo holding the Huelva, Cádiz and Sines refineries, 80% owned by Moeve and 20% by Galp. Talks failed on valuation. With refining margins high but volatile, the sides could not agree what the refineries were worth, and Q3’s EUR 639m of Industrial EBITDA shows why Galp would not sell at a discount. Handing Sines, Portugal’s only refinery, to a platform controlled by Mubadala and Carlyle also raised energy-security concerns, and press reports say the Amorim family, Galp’s largest shareholder, rejected some of Moeve’s demands.</a:t>
+              <a:t>Announced in January, the plan would have created two Iberian platforms: a 50/50 RetailCo with about 3,500 service stations, and an IndustrialCo holding the Huelva, Cádiz and Sines refineries, 80% owned by Moeve and 20% by Galp. With refining margins high but volatile, the sides could not agree what the refineries were worth, and Q3’s EUR 639m of Industrial EBITDA shows why Galp would not sell at a discount. Handing Sines, Portugal’s only refinery, to a platform controlled by Mubadala and Carlyle also raised energy-security concerns, and press reports say the Amorim family, Galp’s largest shareholder, rejected some of Moeve’s demands.</a:t>
             </a:r>
             <a:endParaRPr lang="en-US" sz="870" dirty="0"/>
           </a:p>
@@ -3247,7 +3247,7 @@
         </p:nvSpPr>
         <p:spPr>
           <a:xfrm>
-            <a:off x="539496" y="4711827"/>
+            <a:off x="539496" y="4398035"/>
             <a:ext cx="6483096" cy="219456"/>
           </a:xfrm>
           <a:prstGeom prst="rect">
@@ -3272,6 +3272,87 @@
                 <a:ea typeface="Nunito" pitchFamily="34" charset="-122"/>
                 <a:cs typeface="Nunito" pitchFamily="34" charset="-120"/>
               </a:rPr>
+              <a:t>Brazil: the election adds a risk premium</a:t>
+            </a:r>
+            <a:endParaRPr lang="en-US" sz="1100" dirty="0"/>
+          </a:p>
+        </p:txBody>
+      </p:sp>
+      <p:sp>
+        <p:nvSpPr>
+          <p:cNvPr id="13" name="Text 9"/>
+          <p:cNvSpPr txBox="1"/>
+          <p:nvPr/>
+        </p:nvSpPr>
+        <p:spPr>
+          <a:xfrm>
+            <a:off x="539496" y="4644923"/>
+            <a:ext cx="6483096" cy="645871"/>
+          </a:xfrm>
+          <a:prstGeom prst="rect">
+            <a:avLst/>
+          </a:prstGeom>
+          <a:noFill/>
+          <a:ln/>
+        </p:spPr>
+        <p:txBody>
+          <a:bodyPr wrap="square" lIns="0" tIns="0" rIns="0" bIns="0" rtlCol="0" anchor="t"/>
+          <a:lstStyle/>
+          <a:p>
+            <a:pPr algn="just" indent="0" marL="0">
+              <a:lnSpc>
+                <a:spcPct val="118333"/>
+              </a:lnSpc>
+              <a:buNone/>
+            </a:pPr>
+            <a:r>
+              <a:rPr lang="en-US" sz="870" b="1" dirty="0">
+                <a:solidFill>
+                  <a:srgbClr val="202945"/>
+                </a:solidFill>
+                <a:latin typeface="Nunito" pitchFamily="34" charset="0"/>
+                <a:ea typeface="Nunito" pitchFamily="34" charset="-122"/>
+                <a:cs typeface="Nunito" pitchFamily="34" charset="-120"/>
+              </a:rPr>
+              <a:t>Brazil’s October general election added a smaller headwind to Galp’s earnings engine. To curb fuel prices, the Lula administration introduced a temporary 12% tax on crude exports, which costs Galp up to EUR 100m and helped lift RCA taxes 79% to EUR 493m in Q3. The polarised run-off between President Lula and Flávio Bolsonaro widened Brazil’s sovereign risk premium. We see a discount to monitor, not a change in the case, until the tax lapses.</a:t>
+            </a:r>
+            <a:endParaRPr lang="en-US" sz="870" dirty="0"/>
+          </a:p>
+        </p:txBody>
+      </p:sp>
+      <p:sp>
+        <p:nvSpPr>
+          <p:cNvPr id="14" name="Text 10"/>
+          <p:cNvSpPr txBox="1"/>
+          <p:nvPr/>
+        </p:nvSpPr>
+        <p:spPr>
+          <a:xfrm>
+            <a:off x="539496" y="5406923"/>
+            <a:ext cx="6483096" cy="219456"/>
+          </a:xfrm>
+          <a:prstGeom prst="rect">
+            <a:avLst/>
+          </a:prstGeom>
+          <a:noFill/>
+          <a:ln/>
+        </p:spPr>
+        <p:txBody>
+          <a:bodyPr wrap="square" lIns="0" tIns="0" rIns="0" bIns="0" rtlCol="0" anchor="t"/>
+          <a:lstStyle/>
+          <a:p>
+            <a:pPr indent="0" marL="0">
+              <a:buNone/>
+            </a:pPr>
+            <a:r>
+              <a:rPr lang="en-US" sz="1100" b="1" dirty="0">
+                <a:solidFill>
+                  <a:srgbClr val="202945"/>
+                </a:solidFill>
+                <a:latin typeface="Nunito" pitchFamily="34" charset="0"/>
+                <a:ea typeface="Nunito" pitchFamily="34" charset="-122"/>
+                <a:cs typeface="Nunito" pitchFamily="34" charset="-120"/>
+              </a:rPr>
               <a:t>Valuation: earnings ran ahead of the price</a:t>
             </a:r>
             <a:endParaRPr lang="en-US" sz="1100" dirty="0"/>
@@ -3280,13 +3361,13 @@
       </p:sp>
       <p:sp>
         <p:nvSpPr>
-          <p:cNvPr id="13" name="Text 9"/>
-          <p:cNvSpPr txBox="1"/>
-          <p:nvPr/>
-        </p:nvSpPr>
-        <p:spPr>
-          <a:xfrm>
-            <a:off x="539496" y="4958715"/>
+          <p:cNvPr id="15" name="Text 11"/>
+          <p:cNvSpPr txBox="1"/>
+          <p:nvPr/>
+        </p:nvSpPr>
+        <p:spPr>
+          <a:xfrm>
+            <a:off x="539496" y="5653811"/>
             <a:ext cx="6483096" cy="182880"/>
           </a:xfrm>
           <a:prstGeom prst="rect">
@@ -3333,13 +3414,13 @@
       </p:sp>
       <p:sp>
         <p:nvSpPr>
-          <p:cNvPr id="14" name="Text 10"/>
-          <p:cNvSpPr txBox="1"/>
-          <p:nvPr/>
-        </p:nvSpPr>
-        <p:spPr>
-          <a:xfrm>
-            <a:off x="539496" y="5141595"/>
+          <p:cNvPr id="16" name="Text 12"/>
+          <p:cNvSpPr txBox="1"/>
+          <p:nvPr/>
+        </p:nvSpPr>
+        <p:spPr>
+          <a:xfrm>
+            <a:off x="539496" y="5836691"/>
             <a:ext cx="6483096" cy="237744"/>
           </a:xfrm>
           <a:prstGeom prst="rect">
@@ -3375,7 +3456,7 @@
       </p:sp>
       <p:pic>
         <p:nvPicPr>
-          <p:cNvPr id="15" name="Image 2" descr="/home/claude/galp/c2_crop.png">    </p:cNvPr>
+          <p:cNvPr id="17" name="Image 2" descr="/home/claude/galp/c2_crop.png">    </p:cNvPr>
           <p:cNvPicPr>
             <a:picLocks noChangeAspect="1"/>
           </p:cNvPicPr>
@@ -3389,8 +3470,8 @@
         </p:blipFill>
         <p:spPr>
           <a:xfrm>
-            <a:off x="928482" y="5425059"/>
-            <a:ext cx="5705124" cy="3413946"/>
+            <a:off x="1187806" y="6120155"/>
+            <a:ext cx="5186477" cy="3103588"/>
           </a:xfrm>
           <a:prstGeom prst="rect">
             <a:avLst/>
@@ -3399,13 +3480,13 @@
       </p:pic>
       <p:sp>
         <p:nvSpPr>
-          <p:cNvPr id="16" name="Text 11"/>
-          <p:cNvSpPr txBox="1"/>
-          <p:nvPr/>
-        </p:nvSpPr>
-        <p:spPr>
-          <a:xfrm>
-            <a:off x="539496" y="8893869"/>
+          <p:cNvPr id="18" name="Text 13"/>
+          <p:cNvSpPr txBox="1"/>
+          <p:nvPr/>
+        </p:nvSpPr>
+        <p:spPr>
+          <a:xfrm>
+            <a:off x="539496" y="9278607"/>
             <a:ext cx="6483096" cy="645871"/>
           </a:xfrm>
           <a:prstGeom prst="rect">
@@ -3433,7 +3514,7 @@
                 <a:ea typeface="Nunito" pitchFamily="34" charset="-122"/>
                 <a:cs typeface="Nunito" pitchFamily="34" charset="-120"/>
               </a:rPr>
-              <a:t>Earnings have run well ahead of the share price. Over 12 months, consensus 12m-forward EPS rose 87% to EUR 2.48 while the price gained 24%, so the forward P/E fell from 12.7x to 8.4x, 27% below its 11.6x average since 2022 and under the 10.9x one-year average; results day alone took it down from 9.2x. Removing the full EUR 1.1 of synergy value from the pre-results EUR 22.96 would leave EUR 21.86, or 8.8x: the stock now trades below that, though still 6% above its 40-week average.</a:t>
+              <a:t>Earnings have run well ahead of the share price. Over 12 months, consensus 12m-forward EPS rose 87% to EUR 2.48 while the price gained 24%, so the forward P/E fell from 12.7x to 8.4x, 27% below its 11.6x average since 2022; results day alone took it down from 9.2x. Removing the full EUR 1.1 of synergy value from the pre-results EUR 22.96 would leave EUR 21.86, or 8.8x: the stock now trades below that, though still 6% above its 40-week average.</a:t>
             </a:r>
             <a:endParaRPr lang="en-US" sz="870" dirty="0"/>
           </a:p>

</xml_diff>